<commit_message>
Auditoría de coherencia: referencia el anexo y corrige el conteo de sistemas
- S1: la diapositiva de entrega y la lectura del inventario ahora citan el
  anexo técnico y la guía de la entrega (columnas de algoritmo y llave).
- S2: la lista de revisión cruzada decía "los siete sistemas"; ahora dice
  ocho e incluye correo y directorio, coherente con el caso y la solución.
- S4 y S5: al tratar los cajeros (H6) se cita que el anexo los identifica
  como 3DES cargados a mano en 2019.
- Laboratorios 2 a 6: el encabezado aclara que los minutos por ejercicio son
  ritmo sugerido y que el docente gestiona el tiempo; no se recortó contenido.

Co-Authored-By: Claude Opus 4.8 <noreply@anthropic.com>
</commit_message>
<xml_diff>
--- a/presentaciones/SIO0010-S2-Cifrado-simetrico.pptx
+++ b/presentaciones/SIO0010-S2-Cifrado-simetrico.pptx
@@ -45180,7 +45180,7 @@
                 </a:solidFill>
                 <a:latin typeface="Arial"/>
               </a:rPr>
-              <a:t>¿Aparecen los siete sistemas de la Parte 3 del caso?</a:t>
+              <a:t>¿Aparecen los ocho sistemas de la Parte 3 del caso?</a:t>
             </a:r>
           </a:p>
         </p:txBody>
@@ -45222,7 +45222,7 @@
                 </a:solidFill>
                 <a:latin typeface="Arial"/>
               </a:rPr>
-              <a:t>Core, portal, aplicación, cajeros, procesador, gestor documental y respaldos. Si falta alguno, ¿por qué?</a:t>
+              <a:t>Core, portal, aplicación, cajeros, procesador, gestor documental, respaldos, y correo y directorio. Si falta alguno, ¿por qué?</a:t>
             </a:r>
           </a:p>
         </p:txBody>

</xml_diff>

<commit_message>
Lab 2: corrige el comando del ejercicio 1 y añade el BMP de muestra
Cierra los dos hallazgos de la revisión a fondo de la sesión 2:
- El comando de arranque del ejercicio 1 en el deck cifraba el BMP
  completo (cabecera incluida) pese a decir «cifrar solo los píxeles»;
  ahora separa los 54 bytes de cabecera, cifra solo los píxeles y vuelve
  a unir, igual que el laboratorio.
- Se entrega escudo-plano.bmp (24 bits, colores planos, ancho de 128 px
  para que los píxeles sean múltiplo de 16 y -nopad no falle), referen-
  ciado en el deck y en el laboratorio. Reproducible desde gen_media.py.

Co-Authored-By: Claude Opus 4.8 <noreply@anthropic.com>
</commit_message>
<xml_diff>
--- a/presentaciones/SIO0010-S2-Cifrado-simetrico.pptx
+++ b/presentaciones/SIO0010-S2-Cifrado-simetrico.pptx
@@ -46953,7 +46953,7 @@
         <p:spPr>
           <a:xfrm>
             <a:off x="566928" y="2066543"/>
-            <a:ext cx="11055096" cy="2677363"/>
+            <a:ext cx="11055096" cy="3511296"/>
           </a:xfrm>
           <a:prstGeom prst="rect">
             <a:avLst/>
@@ -47036,7 +47036,7 @@
         <p:spPr>
           <a:xfrm>
             <a:off x="768096" y="2395727"/>
-            <a:ext cx="10652760" cy="2256739"/>
+            <a:ext cx="10652760" cy="3090672"/>
           </a:xfrm>
           <a:prstGeom prst="rect">
             <a:avLst/>
@@ -47064,7 +47064,7 @@
                 </a:solidFill>
                 <a:latin typeface="Consolas"/>
               </a:rPr>
-              <a:t># Ejercicio 1 — conservar la cabecera del archivo y cifrar solo los píxeles</a:t>
+              <a:t># Ejercicio 1 — separar la cabecera y cifrar solo los píxeles (BMP de muestra: escudo-plano.bmp)</a:t>
             </a:r>
           </a:p>
           <a:p>
@@ -47083,7 +47083,7 @@
                 </a:solidFill>
                 <a:latin typeface="Consolas"/>
               </a:rPr>
-              <a:t>openssl enc -aes-256-ecb -in imagen.bmp -out ecb.bin -K &lt;llave_hex&gt; -nopad</a:t>
+              <a:t>head -c 54 escudo-plano.bmp &gt; cab.bin        # la cabecera del BMP son 54 bytes</a:t>
             </a:r>
           </a:p>
           <a:p>
@@ -47102,7 +47102,83 @@
                 </a:solidFill>
                 <a:latin typeface="Consolas"/>
               </a:rPr>
-              <a:t>openssl enc -aes-256-cbc -in imagen.bmp -out cbc.bin -K &lt;llave_hex&gt; -iv &lt;vi_hex&gt; -nopad</a:t>
+              <a:t>tail -c +55 escudo-plano.bmp &gt; pix.bin       # el resto son los píxeles</a:t>
+            </a:r>
+          </a:p>
+          <a:p>
+            <a:pPr algn="l">
+              <a:lnSpc>
+                <a:spcPct val="130000"/>
+              </a:lnSpc>
+              <a:spcAft>
+                <a:spcPts val="0"/>
+              </a:spcAft>
+            </a:pPr>
+            <a:r>
+              <a:rPr sz="950" b="0">
+                <a:solidFill>
+                  <a:srgbClr val="000000"/>
+                </a:solidFill>
+                <a:latin typeface="Consolas"/>
+              </a:rPr>
+              <a:t>openssl enc -aes-256-ecb -in pix.bin -out ecb.bin -K &lt;llave_hex&gt; -nopad</a:t>
+            </a:r>
+          </a:p>
+          <a:p>
+            <a:pPr algn="l">
+              <a:lnSpc>
+                <a:spcPct val="130000"/>
+              </a:lnSpc>
+              <a:spcAft>
+                <a:spcPts val="0"/>
+              </a:spcAft>
+            </a:pPr>
+            <a:r>
+              <a:rPr sz="950" b="0">
+                <a:solidFill>
+                  <a:srgbClr val="000000"/>
+                </a:solidFill>
+                <a:latin typeface="Consolas"/>
+              </a:rPr>
+              <a:t>openssl enc -aes-256-cbc -in pix.bin -out cbc.bin -K &lt;llave_hex&gt; -iv &lt;vi_hex&gt; -nopad</a:t>
+            </a:r>
+          </a:p>
+          <a:p>
+            <a:pPr algn="l">
+              <a:lnSpc>
+                <a:spcPct val="130000"/>
+              </a:lnSpc>
+              <a:spcAft>
+                <a:spcPts val="0"/>
+              </a:spcAft>
+            </a:pPr>
+            <a:r>
+              <a:rPr sz="950" b="0">
+                <a:solidFill>
+                  <a:srgbClr val="000000"/>
+                </a:solidFill>
+                <a:latin typeface="Consolas"/>
+              </a:rPr>
+              <a:t>cat cab.bin ecb.bin &gt; escudo-ecb.bmp         # unir cabecera + píxeles para poder abrirlo</a:t>
+            </a:r>
+          </a:p>
+          <a:p>
+            <a:pPr algn="l">
+              <a:lnSpc>
+                <a:spcPct val="130000"/>
+              </a:lnSpc>
+              <a:spcAft>
+                <a:spcPts val="0"/>
+              </a:spcAft>
+            </a:pPr>
+            <a:r>
+              <a:rPr sz="950" b="0">
+                <a:solidFill>
+                  <a:srgbClr val="000000"/>
+                </a:solidFill>
+                <a:latin typeface="Consolas"/>
+              </a:rPr>
+              <a:t>cat cab.bin cbc.bin &gt; escudo-cbc.bmp</a:t>
             </a:r>
           </a:p>
           <a:p>

</xml_diff>

<commit_message>
Aclara la terminal: los comandos van en Git Bash, no en cmd
En Windows, cmd.exe y PowerShell no tienen openssl ni head/tail/cat, y
los ejercicios con OpenSSL fallan ahí. Se añade una nota en los labs 2-5
y en los decks (S1 «entorno de trabajo» y S2 «comandos de arranque»):
en Windows van en Git Bash; en macOS y Linux, en la Terminal; la
alternativa en Python corre en cualquier terminal.

Co-Authored-By: Claude Opus 4.8 <noreply@anthropic.com>
</commit_message>
<xml_diff>
--- a/presentaciones/SIO0010-S2-Cifrado-simetrico.pptx
+++ b/presentaciones/SIO0010-S2-Cifrado-simetrico.pptx
@@ -46911,7 +46911,7 @@
         <p:spPr>
           <a:xfrm>
             <a:off x="566928" y="1554480"/>
-            <a:ext cx="11055096" cy="237744"/>
+            <a:ext cx="11055096" cy="475488"/>
           </a:xfrm>
           <a:prstGeom prst="rect">
             <a:avLst/>
@@ -46939,7 +46939,7 @@
                 </a:solidFill>
                 <a:latin typeface="Arial"/>
               </a:rPr>
-              <a:t>Suficiente para empezar. Lo demás está en la guía de laboratorio que se les entrega.</a:t>
+              <a:t>Suficiente para empezar. En Windows van en Git Bash —no en cmd ni PowerShell—, que trae OpenSSL y las órdenes head, tail y cat. Lo demás está en la guía de laboratorio.</a:t>
             </a:r>
           </a:p>
         </p:txBody>
@@ -46952,7 +46952,7 @@
         </p:nvSpPr>
         <p:spPr>
           <a:xfrm>
-            <a:off x="566928" y="2066543"/>
+            <a:off x="566928" y="2304287"/>
             <a:ext cx="11055096" cy="3511296"/>
           </a:xfrm>
           <a:prstGeom prst="rect">
@@ -46996,7 +46996,7 @@
         </p:nvSpPr>
         <p:spPr>
           <a:xfrm>
-            <a:off x="768096" y="2157984"/>
+            <a:off x="768096" y="2395727"/>
             <a:ext cx="10652760" cy="182880"/>
           </a:xfrm>
           <a:prstGeom prst="rect">
@@ -47035,7 +47035,7 @@
         </p:nvSpPr>
         <p:spPr>
           <a:xfrm>
-            <a:off x="768096" y="2395727"/>
+            <a:off x="768096" y="2633471"/>
             <a:ext cx="10652760" cy="3090672"/>
           </a:xfrm>
           <a:prstGeom prst="rect">

</xml_diff>